<commit_message>
Drop tunnel artwork from cover and closing; export slide images
Cover and closing now carry an info band (일시·장소·발표 / 훈련·주관)
instead of the tunnel illustration. render_images.js exports every slide
of the HTML draft as a 1920x1080 PNG into images/ for sharing.

Co-Authored-By: Claude Opus 5.5 <noreply@anthropic.com>
Claude-Session: https://claude.ai/code/session_015YmmV8DLjTJs9DKwfoGABq
</commit_message>
<xml_diff>
--- a/briefing/onseok-tunnel/onseok-briefing.pptx
+++ b/briefing/onseok-tunnel/onseok-briefing.pptx
@@ -120,48 +120,48 @@
   <p:extLst>
     <p:ext uri="{521415D9-36F7-43E2-AB2F-B90AF26B5E84}">
       <p14:sectionLst xmlns:p14="http://schemas.microsoft.com/office/powerpoint/2010/main">
-        <p14:section name="표지" id="{2402713b-3443-d8bb-f636-50e194f56fde}">
+        <p14:section name="표지" id="{125b6f55-b7af-f35f-cb0b-951d977237a9}">
           <p14:sldIdLst>
             <p14:sldId id="256"/>
             <p14:sldId id="257"/>
           </p14:sldIdLst>
         </p14:section>
-        <p14:section name="01 훈련목적 및 추진체계" id="{b1851344-5368-9cc1-e228-43d9a2b9ead8}">
+        <p14:section name="01 훈련목적 및 추진체계" id="{539940d1-e54f-b43c-8281-583586d61f08}">
           <p14:sldIdLst>
             <p14:sldId id="258"/>
           </p14:sldIdLst>
         </p14:section>
-        <p14:section name="02 도로터널 훈련배경" id="{8da1f26c-874d-f2af-a2f9-394b5da1af28}">
+        <p14:section name="02 도로터널 훈련배경" id="{c3f08094-1a65-2eae-9841-f4e4084f6c45}">
           <p14:sldIdLst>
             <p14:sldId id="259"/>
             <p14:sldId id="260"/>
           </p14:sldIdLst>
         </p14:section>
-        <p14:section name="03 훈련개요 및 중점사항" id="{03e016eb-1241-f2ad-a6df-7b9b97fc2578}">
+        <p14:section name="03 훈련개요 및 중점사항" id="{3f2c603f-6e7d-70b8-f486-89101f5c013f}">
           <p14:sldIdLst>
             <p14:sldId id="261"/>
             <p14:sldId id="262"/>
             <p14:sldId id="263"/>
           </p14:sldIdLst>
         </p14:section>
-        <p14:section name="04 온석터널 시설현황 및 특성" id="{e5ebb9d4-74ee-778f-6deb-1efbc9d8a272}">
+        <p14:section name="04 온석터널 시설현황 및 특성" id="{9a3408aa-39f6-f565-7b60-b09532e5da49}">
           <p14:sldIdLst>
             <p14:sldId id="264"/>
           </p14:sldIdLst>
         </p14:section>
-        <p14:section name="05 교통통제 및 우회도로 운영" id="{f0aa7378-97de-e480-d84d-a620d6d702ef}">
+        <p14:section name="05 교통통제 및 우회도로 운영" id="{633c8836-7fd9-1742-6ca0-4572129357d6}">
           <p14:sldIdLst>
             <p14:sldId id="265"/>
           </p14:sldIdLst>
         </p14:section>
-        <p14:section name="06 상황전파 및 기관별 대응체계" id="{2e526abe-d11a-3c63-b301-2163eec77c2b}">
+        <p14:section name="06 상황전파 및 기관별 대응체계" id="{c8467c11-c8ae-dddc-a257-def3af3c1a3b}">
           <p14:sldIdLst>
             <p14:sldId id="266"/>
             <p14:sldId id="267"/>
             <p14:sldId id="268"/>
           </p14:sldIdLst>
         </p14:section>
-        <p14:section name="마무리" id="{1e118b3a-ae38-0860-946a-bcdcafe23e1a}">
+        <p14:section name="마무리" id="{57abf130-9c40-b379-4a3f-856a2cc3e564}">
           <p14:sldIdLst>
             <p14:sldId id="269"/>
           </p14:sldIdLst>
@@ -1820,8 +1820,8 @@
         </p:nvSpPr>
         <p:spPr>
           <a:xfrm>
-            <a:off x="685800" y="2247900"/>
-            <a:ext cx="5334000" cy="1714500"/>
+            <a:off x="685800" y="1790700"/>
+            <a:ext cx="10820400" cy="1866900"/>
           </a:xfrm>
           <a:prstGeom prst="rect">
             <a:avLst/>
@@ -1837,7 +1837,7 @@
                 <a:spcPct val="97600"/>
               </a:lnSpc>
               <a:buNone/>
-              <a:defRPr lang="en-US" sz="5400" spc="-100" kern="0" dirty="0">
+              <a:defRPr lang="en-US" sz="6400" spc="-100" kern="0" dirty="0">
                 <a:solidFill>
                   <a:schemeClr val="bg1"/>
                 </a:solidFill>
@@ -1854,7 +1854,7 @@
               </a:lnSpc>
               <a:buNone/>
             </a:pPr>
-            <a:endParaRPr lang="en-US" sz="5400" dirty="0"/>
+            <a:endParaRPr lang="en-US" sz="6400" dirty="0"/>
           </a:p>
         </p:txBody>
       </p:sp>
@@ -1900,8 +1900,8 @@
         </p:nvSpPr>
         <p:spPr>
           <a:xfrm>
-            <a:off x="685800" y="2571750"/>
-            <a:ext cx="4953000" cy="914400"/>
+            <a:off x="685800" y="2247900"/>
+            <a:ext cx="10820400" cy="1047750"/>
           </a:xfrm>
           <a:prstGeom prst="rect">
             <a:avLst/>
@@ -1917,7 +1917,7 @@
                 <a:spcPct val="97600"/>
               </a:lnSpc>
               <a:buNone/>
-              <a:defRPr lang="en-US" sz="6000" spc="-100" kern="0" dirty="0">
+              <a:defRPr lang="en-US" sz="7200" spc="-100" kern="0" dirty="0">
                 <a:solidFill>
                   <a:schemeClr val="bg1"/>
                 </a:solidFill>
@@ -1934,7 +1934,7 @@
               </a:lnSpc>
               <a:buNone/>
             </a:pPr>
-            <a:endParaRPr lang="en-US" sz="6000" dirty="0"/>
+            <a:endParaRPr lang="en-US" sz="7200" dirty="0"/>
           </a:p>
         </p:txBody>
       </p:sp>
@@ -2662,8 +2662,8 @@
         </p:nvSpPr>
         <p:spPr>
           <a:xfrm>
-            <a:off x="685800" y="2247900"/>
-            <a:ext cx="5334000" cy="1714500"/>
+            <a:off x="685800" y="1790700"/>
+            <a:ext cx="10820400" cy="1866900"/>
           </a:xfrm>
           <a:prstGeom prst="rect">
             <a:avLst/>
@@ -2682,7 +2682,7 @@
               <a:buNone/>
             </a:pPr>
             <a:r>
-              <a:rPr lang="ko-KR" altLang="en-US" sz="5400" spc="-100" kern="0" dirty="0">
+              <a:rPr lang="ko-KR" altLang="en-US" sz="6400" spc="-100" kern="0" dirty="0">
                 <a:solidFill>
                   <a:schemeClr val="bg1"/>
                 </a:solidFill>
@@ -2692,7 +2692,7 @@
               </a:rPr>
               <a:t>온석터널</a:t>
             </a:r>
-            <a:endParaRPr lang="en-US" sz="5400" dirty="0"/>
+            <a:endParaRPr lang="en-US" sz="6400" dirty="0"/>
           </a:p>
           <a:p>
             <a:pPr algn="l" indent="0" marL="0">
@@ -2702,7 +2702,7 @@
               <a:buNone/>
             </a:pPr>
             <a:r>
-              <a:rPr lang="ko-KR" altLang="en-US" sz="5400" spc="-100" kern="0" dirty="0">
+              <a:rPr lang="ko-KR" altLang="en-US" sz="6400" spc="-100" kern="0" dirty="0">
                 <a:solidFill>
                   <a:schemeClr val="bg1"/>
                 </a:solidFill>
@@ -2712,44 +2712,20 @@
               </a:rPr>
               <a:t>훈련개요 브리핑</a:t>
             </a:r>
-            <a:endParaRPr lang="en-US" sz="5400" dirty="0"/>
-          </a:p>
-        </p:txBody>
-      </p:sp>
-      <p:pic>
-        <p:nvPicPr>
-          <p:cNvPr id="3" name="Tunnel artwork" descr="">    </p:cNvPr>
-          <p:cNvPicPr>
-            <a:picLocks noChangeAspect="1"/>
-          </p:cNvPicPr>
-          <p:nvPr/>
-        </p:nvPicPr>
-        <p:blipFill>
-          <a:blip r:embed="rId1"/>
-          <a:stretch>
-            <a:fillRect/>
-          </a:stretch>
-        </p:blipFill>
-        <p:spPr>
-          <a:xfrm>
-            <a:off x="5334000" y="0"/>
-            <a:ext cx="6858000" cy="6858000"/>
-          </a:xfrm>
-          <a:prstGeom prst="rect">
-            <a:avLst/>
-          </a:prstGeom>
-        </p:spPr>
-      </p:pic>
-      <p:sp>
-        <p:nvSpPr>
-          <p:cNvPr id="4" name="Text 1"/>
-          <p:cNvSpPr txBox="1"/>
-          <p:nvPr/>
-        </p:nvSpPr>
-        <p:spPr>
-          <a:xfrm>
-            <a:off x="685800" y="1847850"/>
-            <a:ext cx="4953000" cy="285750"/>
+            <a:endParaRPr lang="en-US" sz="6400" dirty="0"/>
+          </a:p>
+        </p:txBody>
+      </p:sp>
+      <p:sp>
+        <p:nvSpPr>
+          <p:cNvPr id="3" name="Text 1"/>
+          <p:cNvSpPr txBox="1"/>
+          <p:nvPr/>
+        </p:nvSpPr>
+        <p:spPr>
+          <a:xfrm>
+            <a:off x="685800" y="1409700"/>
+            <a:ext cx="5715000" cy="285750"/>
           </a:xfrm>
           <a:prstGeom prst="rect">
             <a:avLst/>
@@ -2784,14 +2760,14 @@
       </p:sp>
       <p:sp>
         <p:nvSpPr>
-          <p:cNvPr id="5" name="Text 2"/>
-          <p:cNvSpPr txBox="1"/>
-          <p:nvPr/>
-        </p:nvSpPr>
-        <p:spPr>
-          <a:xfrm>
-            <a:off x="685800" y="4076700"/>
-            <a:ext cx="5715000" cy="285750"/>
+          <p:cNvPr id="4" name="Text 2"/>
+          <p:cNvSpPr txBox="1"/>
+          <p:nvPr/>
+        </p:nvSpPr>
+        <p:spPr>
+          <a:xfrm>
+            <a:off x="685800" y="3810000"/>
+            <a:ext cx="7620000" cy="304800"/>
           </a:xfrm>
           <a:prstGeom prst="rect">
             <a:avLst/>
@@ -2810,7 +2786,7 @@
               <a:buNone/>
             </a:pPr>
             <a:r>
-              <a:rPr lang="ko-KR" altLang="en-US" sz="1700" dirty="0">
+              <a:rPr lang="ko-KR" altLang="en-US" sz="2000" dirty="0">
                 <a:solidFill>
                   <a:schemeClr val="accent4"/>
                 </a:solidFill>
@@ -2818,22 +2794,46 @@
                 <a:ea typeface="Paperlogy 5 Medium" pitchFamily="34" charset="-127"/>
                 <a:cs typeface="Paperlogy 5 Medium" pitchFamily="34" charset="-120"/>
               </a:rPr>
-              <a:t>도로 분야 복합재난 대응훈련  |  국도32호선 온석터널</a:t>
-            </a:r>
-            <a:endParaRPr lang="ko-KR" sz="1700" dirty="0"/>
-          </a:p>
-        </p:txBody>
-      </p:sp>
-      <p:sp>
-        <p:nvSpPr>
-          <p:cNvPr id="6" name="Text 3"/>
-          <p:cNvSpPr txBox="1"/>
-          <p:nvPr/>
-        </p:nvSpPr>
-        <p:spPr>
-          <a:xfrm>
-            <a:off x="685800" y="5200650"/>
-            <a:ext cx="4572000" cy="323850"/>
+              <a:t>도로 분야 복합재난 대응훈련</a:t>
+            </a:r>
+            <a:endParaRPr lang="ko-KR" sz="2000" dirty="0"/>
+          </a:p>
+        </p:txBody>
+      </p:sp>
+      <p:sp>
+        <p:nvSpPr>
+          <p:cNvPr id="5" name="Info band"/>
+          <p:cNvSpPr/>
+          <p:nvPr/>
+        </p:nvSpPr>
+        <p:spPr>
+          <a:xfrm>
+            <a:off x="685800" y="4876800"/>
+            <a:ext cx="10820400" cy="1066800"/>
+          </a:xfrm>
+          <a:prstGeom prst="roundRect">
+            <a:avLst>
+              <a:gd name="adj" fmla="val 16071"/>
+            </a:avLst>
+          </a:prstGeom>
+          <a:solidFill>
+            <a:schemeClr val="bg1">
+              <a:alpha val="6000"/>
+            </a:schemeClr>
+          </a:solidFill>
+          <a:ln/>
+        </p:spPr>
+      </p:sp>
+      <p:sp>
+        <p:nvSpPr>
+          <p:cNvPr id="6" name="Text 4"/>
+          <p:cNvSpPr txBox="1"/>
+          <p:nvPr/>
+        </p:nvSpPr>
+        <p:spPr>
+          <a:xfrm>
+            <a:off x="990600" y="5086350"/>
+            <a:ext cx="3657600" cy="228600"/>
           </a:xfrm>
           <a:prstGeom prst="rect">
             <a:avLst/>
@@ -2852,30 +2852,95 @@
               <a:buNone/>
             </a:pPr>
             <a:r>
-              <a:rPr lang="ko-KR" altLang="en-US" sz="2000" dirty="0">
+              <a:rPr lang="ko-KR" altLang="en-US" sz="1300" dirty="0">
                 <a:solidFill>
                   <a:schemeClr val="accent3"/>
+                </a:solidFill>
+                <a:latin typeface="Paperlogy 6 SemiBold" pitchFamily="34" charset="0"/>
+                <a:ea typeface="Paperlogy 6 SemiBold" pitchFamily="34" charset="-127"/>
+                <a:cs typeface="Paperlogy 6 SemiBold" pitchFamily="34" charset="-120"/>
+              </a:rPr>
+              <a:t>일시</a:t>
+            </a:r>
+            <a:endParaRPr lang="ko-KR" sz="1300" dirty="0"/>
+          </a:p>
+        </p:txBody>
+      </p:sp>
+      <p:sp>
+        <p:nvSpPr>
+          <p:cNvPr id="7" name="Text 5"/>
+          <p:cNvSpPr txBox="1"/>
+          <p:nvPr/>
+        </p:nvSpPr>
+        <p:spPr>
+          <a:xfrm>
+            <a:off x="990600" y="5353050"/>
+            <a:ext cx="3657600" cy="323850"/>
+          </a:xfrm>
+          <a:prstGeom prst="rect">
+            <a:avLst/>
+          </a:prstGeom>
+          <a:noFill/>
+          <a:ln/>
+        </p:spPr>
+        <p:txBody>
+          <a:bodyPr wrap="square" lIns="0" tIns="0" rIns="0" bIns="0" rtlCol="0" anchor="ctr"/>
+          <a:lstStyle/>
+          <a:p>
+            <a:pPr algn="l" indent="0" marL="0">
+              <a:lnSpc>
+                <a:spcPct val="101900"/>
+              </a:lnSpc>
+              <a:buNone/>
+            </a:pPr>
+            <a:r>
+              <a:rPr lang="ko-KR" altLang="en-US" sz="1700" dirty="0">
+                <a:solidFill>
+                  <a:schemeClr val="bg1"/>
                 </a:solidFill>
                 <a:latin typeface="Paperlogy 7 Bold" pitchFamily="34" charset="0"/>
                 <a:ea typeface="Paperlogy 7 Bold" pitchFamily="34" charset="-127"/>
                 <a:cs typeface="Paperlogy 7 Bold" pitchFamily="34" charset="-120"/>
               </a:rPr>
-              <a:t>2026. 10. 22. (목)</a:t>
-            </a:r>
-            <a:endParaRPr lang="ko-KR" sz="2000" dirty="0"/>
-          </a:p>
-        </p:txBody>
-      </p:sp>
-      <p:sp>
-        <p:nvSpPr>
-          <p:cNvPr id="7" name="Text 4"/>
-          <p:cNvSpPr txBox="1"/>
-          <p:nvPr/>
-        </p:nvSpPr>
-        <p:spPr>
-          <a:xfrm>
-            <a:off x="685800" y="5581650"/>
-            <a:ext cx="5715000" cy="266700"/>
+              <a:t>2026. 10. 22. (목) 14:00 ~ 16:00</a:t>
+            </a:r>
+            <a:endParaRPr lang="ko-KR" sz="1700" dirty="0"/>
+          </a:p>
+        </p:txBody>
+      </p:sp>
+      <p:sp>
+        <p:nvSpPr>
+          <p:cNvPr id="8" name="Shape 6"/>
+          <p:cNvSpPr/>
+          <p:nvPr/>
+        </p:nvSpPr>
+        <p:spPr>
+          <a:xfrm>
+            <a:off x="4876800" y="5143500"/>
+            <a:ext cx="0" cy="533400"/>
+          </a:xfrm>
+          <a:prstGeom prst="line">
+            <a:avLst/>
+          </a:prstGeom>
+          <a:noFill/>
+          <a:ln w="14288">
+            <a:solidFill>
+              <a:schemeClr val="accent1"/>
+            </a:solidFill>
+            <a:prstDash val="solid"/>
+          </a:ln>
+        </p:spPr>
+      </p:sp>
+      <p:sp>
+        <p:nvSpPr>
+          <p:cNvPr id="9" name="Text 7"/>
+          <p:cNvSpPr txBox="1"/>
+          <p:nvPr/>
+        </p:nvSpPr>
+        <p:spPr>
+          <a:xfrm>
+            <a:off x="5105400" y="5086350"/>
+            <a:ext cx="2857500" cy="228600"/>
           </a:xfrm>
           <a:prstGeom prst="rect">
             <a:avLst/>
@@ -2894,17 +2959,166 @@
               <a:buNone/>
             </a:pPr>
             <a:r>
-              <a:rPr lang="ko-KR" altLang="en-US" sz="1600" dirty="0">
+              <a:rPr lang="ko-KR" altLang="en-US" sz="1300" dirty="0">
+                <a:solidFill>
+                  <a:schemeClr val="accent3"/>
+                </a:solidFill>
+                <a:latin typeface="Paperlogy 6 SemiBold" pitchFamily="34" charset="0"/>
+                <a:ea typeface="Paperlogy 6 SemiBold" pitchFamily="34" charset="-127"/>
+                <a:cs typeface="Paperlogy 6 SemiBold" pitchFamily="34" charset="-120"/>
+              </a:rPr>
+              <a:t>장소</a:t>
+            </a:r>
+            <a:endParaRPr lang="ko-KR" sz="1300" dirty="0"/>
+          </a:p>
+        </p:txBody>
+      </p:sp>
+      <p:sp>
+        <p:nvSpPr>
+          <p:cNvPr id="10" name="Text 8"/>
+          <p:cNvSpPr txBox="1"/>
+          <p:nvPr/>
+        </p:nvSpPr>
+        <p:spPr>
+          <a:xfrm>
+            <a:off x="5105400" y="5353050"/>
+            <a:ext cx="2857500" cy="323850"/>
+          </a:xfrm>
+          <a:prstGeom prst="rect">
+            <a:avLst/>
+          </a:prstGeom>
+          <a:noFill/>
+          <a:ln/>
+        </p:spPr>
+        <p:txBody>
+          <a:bodyPr wrap="square" lIns="0" tIns="0" rIns="0" bIns="0" rtlCol="0" anchor="ctr"/>
+          <a:lstStyle/>
+          <a:p>
+            <a:pPr algn="l" indent="0" marL="0">
+              <a:lnSpc>
+                <a:spcPct val="101900"/>
+              </a:lnSpc>
+              <a:buNone/>
+            </a:pPr>
+            <a:r>
+              <a:rPr lang="ko-KR" altLang="en-US" sz="1700" dirty="0">
                 <a:solidFill>
                   <a:schemeClr val="bg1"/>
                 </a:solidFill>
-                <a:latin typeface="Paperlogy 5 Medium" pitchFamily="34" charset="0"/>
-                <a:ea typeface="Paperlogy 5 Medium" pitchFamily="34" charset="-127"/>
-                <a:cs typeface="Paperlogy 5 Medium" pitchFamily="34" charset="-120"/>
-              </a:rPr>
-              <a:t>예산국토관리사무소  시설안전관리과장  최병목</a:t>
-            </a:r>
-            <a:endParaRPr lang="ko-KR" sz="1600" dirty="0"/>
+                <a:latin typeface="Paperlogy 7 Bold" pitchFamily="34" charset="0"/>
+                <a:ea typeface="Paperlogy 7 Bold" pitchFamily="34" charset="-127"/>
+                <a:cs typeface="Paperlogy 7 Bold" pitchFamily="34" charset="-120"/>
+              </a:rPr>
+              <a:t>국도32호선 온석터널 서산방향</a:t>
+            </a:r>
+            <a:endParaRPr lang="ko-KR" sz="1700" dirty="0"/>
+          </a:p>
+        </p:txBody>
+      </p:sp>
+      <p:sp>
+        <p:nvSpPr>
+          <p:cNvPr id="11" name="Shape 9"/>
+          <p:cNvSpPr/>
+          <p:nvPr/>
+        </p:nvSpPr>
+        <p:spPr>
+          <a:xfrm>
+            <a:off x="8191500" y="5143500"/>
+            <a:ext cx="0" cy="533400"/>
+          </a:xfrm>
+          <a:prstGeom prst="line">
+            <a:avLst/>
+          </a:prstGeom>
+          <a:noFill/>
+          <a:ln w="14288">
+            <a:solidFill>
+              <a:schemeClr val="accent1"/>
+            </a:solidFill>
+            <a:prstDash val="solid"/>
+          </a:ln>
+        </p:spPr>
+      </p:sp>
+      <p:sp>
+        <p:nvSpPr>
+          <p:cNvPr id="12" name="Text 10"/>
+          <p:cNvSpPr txBox="1"/>
+          <p:nvPr/>
+        </p:nvSpPr>
+        <p:spPr>
+          <a:xfrm>
+            <a:off x="8420100" y="5086350"/>
+            <a:ext cx="2819400" cy="228600"/>
+          </a:xfrm>
+          <a:prstGeom prst="rect">
+            <a:avLst/>
+          </a:prstGeom>
+          <a:noFill/>
+          <a:ln/>
+        </p:spPr>
+        <p:txBody>
+          <a:bodyPr wrap="square" lIns="0" tIns="0" rIns="0" bIns="0" rtlCol="0" anchor="ctr"/>
+          <a:lstStyle/>
+          <a:p>
+            <a:pPr algn="l" indent="0" marL="0">
+              <a:lnSpc>
+                <a:spcPct val="101900"/>
+              </a:lnSpc>
+              <a:buNone/>
+            </a:pPr>
+            <a:r>
+              <a:rPr lang="ko-KR" altLang="en-US" sz="1300" dirty="0">
+                <a:solidFill>
+                  <a:schemeClr val="accent3"/>
+                </a:solidFill>
+                <a:latin typeface="Paperlogy 6 SemiBold" pitchFamily="34" charset="0"/>
+                <a:ea typeface="Paperlogy 6 SemiBold" pitchFamily="34" charset="-127"/>
+                <a:cs typeface="Paperlogy 6 SemiBold" pitchFamily="34" charset="-120"/>
+              </a:rPr>
+              <a:t>발표 · 예산국토관리사무소</a:t>
+            </a:r>
+            <a:endParaRPr lang="ko-KR" sz="1300" dirty="0"/>
+          </a:p>
+        </p:txBody>
+      </p:sp>
+      <p:sp>
+        <p:nvSpPr>
+          <p:cNvPr id="13" name="Text 11"/>
+          <p:cNvSpPr txBox="1"/>
+          <p:nvPr/>
+        </p:nvSpPr>
+        <p:spPr>
+          <a:xfrm>
+            <a:off x="8420100" y="5353050"/>
+            <a:ext cx="2819400" cy="323850"/>
+          </a:xfrm>
+          <a:prstGeom prst="rect">
+            <a:avLst/>
+          </a:prstGeom>
+          <a:noFill/>
+          <a:ln/>
+        </p:spPr>
+        <p:txBody>
+          <a:bodyPr wrap="square" lIns="0" tIns="0" rIns="0" bIns="0" rtlCol="0" anchor="ctr"/>
+          <a:lstStyle/>
+          <a:p>
+            <a:pPr algn="l" indent="0" marL="0">
+              <a:lnSpc>
+                <a:spcPct val="101900"/>
+              </a:lnSpc>
+              <a:buNone/>
+            </a:pPr>
+            <a:r>
+              <a:rPr lang="ko-KR" altLang="en-US" sz="1700" dirty="0">
+                <a:solidFill>
+                  <a:schemeClr val="bg1"/>
+                </a:solidFill>
+                <a:latin typeface="Paperlogy 7 Bold" pitchFamily="34" charset="0"/>
+                <a:ea typeface="Paperlogy 7 Bold" pitchFamily="34" charset="-127"/>
+                <a:cs typeface="Paperlogy 7 Bold" pitchFamily="34" charset="-120"/>
+              </a:rPr>
+              <a:t>시설안전관리과장 최병목</a:t>
+            </a:r>
+            <a:endParaRPr lang="ko-KR" sz="1700" dirty="0"/>
           </a:p>
         </p:txBody>
       </p:sp>
@@ -8581,8 +8795,8 @@
         </p:nvSpPr>
         <p:spPr>
           <a:xfrm>
-            <a:off x="685800" y="2571750"/>
-            <a:ext cx="4953000" cy="914400"/>
+            <a:off x="685800" y="2247900"/>
+            <a:ext cx="10820400" cy="1047750"/>
           </a:xfrm>
           <a:prstGeom prst="rect">
             <a:avLst/>
@@ -8601,7 +8815,7 @@
               <a:buNone/>
             </a:pPr>
             <a:r>
-              <a:rPr lang="ko-KR" altLang="en-US" sz="6000" spc="-100" kern="0" dirty="0">
+              <a:rPr lang="ko-KR" altLang="en-US" sz="7200" spc="-100" kern="0" dirty="0">
                 <a:solidFill>
                   <a:schemeClr val="bg1"/>
                 </a:solidFill>
@@ -8611,44 +8825,20 @@
               </a:rPr>
               <a:t>감사합니다</a:t>
             </a:r>
-            <a:endParaRPr lang="en-US" sz="6000" dirty="0"/>
-          </a:p>
-        </p:txBody>
-      </p:sp>
-      <p:pic>
-        <p:nvPicPr>
-          <p:cNvPr id="3" name="Tunnel artwork" descr="">    </p:cNvPr>
-          <p:cNvPicPr>
-            <a:picLocks noChangeAspect="1"/>
-          </p:cNvPicPr>
-          <p:nvPr/>
-        </p:nvPicPr>
-        <p:blipFill>
-          <a:blip r:embed="rId1"/>
-          <a:stretch>
-            <a:fillRect/>
-          </a:stretch>
-        </p:blipFill>
-        <p:spPr>
-          <a:xfrm>
-            <a:off x="5334000" y="0"/>
-            <a:ext cx="6858000" cy="6858000"/>
-          </a:xfrm>
-          <a:prstGeom prst="rect">
-            <a:avLst/>
-          </a:prstGeom>
-        </p:spPr>
-      </p:pic>
-      <p:sp>
-        <p:nvSpPr>
-          <p:cNvPr id="4" name="Text 1"/>
-          <p:cNvSpPr txBox="1"/>
-          <p:nvPr/>
-        </p:nvSpPr>
-        <p:spPr>
-          <a:xfrm>
-            <a:off x="685800" y="2171700"/>
-            <a:ext cx="4953000" cy="285750"/>
+            <a:endParaRPr lang="en-US" sz="7200" dirty="0"/>
+          </a:p>
+        </p:txBody>
+      </p:sp>
+      <p:sp>
+        <p:nvSpPr>
+          <p:cNvPr id="3" name="Text 1"/>
+          <p:cNvSpPr txBox="1"/>
+          <p:nvPr/>
+        </p:nvSpPr>
+        <p:spPr>
+          <a:xfrm>
+            <a:off x="685800" y="1866900"/>
+            <a:ext cx="5715000" cy="285750"/>
           </a:xfrm>
           <a:prstGeom prst="rect">
             <a:avLst/>
@@ -8683,33 +8873,33 @@
       </p:sp>
       <p:sp>
         <p:nvSpPr>
-          <p:cNvPr id="5" name="Text 2"/>
-          <p:cNvSpPr txBox="1"/>
-          <p:nvPr/>
-        </p:nvSpPr>
-        <p:spPr>
-          <a:xfrm>
-            <a:off x="685800" y="3657600"/>
-            <a:ext cx="4953000" cy="723900"/>
-          </a:xfrm>
-          <a:prstGeom prst="rect">
-            <a:avLst/>
-          </a:prstGeom>
-          <a:noFill/>
-          <a:ln/>
-        </p:spPr>
-        <p:txBody>
-          <a:bodyPr wrap="square" lIns="0" tIns="0" rIns="0" bIns="0" rtlCol="0" anchor="t"/>
-          <a:lstStyle/>
-          <a:p>
-            <a:pPr algn="l" indent="0" marL="0">
-              <a:lnSpc>
-                <a:spcPct val="127400"/>
-              </a:lnSpc>
-              <a:buNone/>
-            </a:pPr>
-            <a:r>
-              <a:rPr lang="ko-KR" altLang="en-US" sz="1900" dirty="0">
+          <p:cNvPr id="4" name="Text 2"/>
+          <p:cNvSpPr txBox="1"/>
+          <p:nvPr/>
+        </p:nvSpPr>
+        <p:spPr>
+          <a:xfrm>
+            <a:off x="685800" y="3409950"/>
+            <a:ext cx="8572500" cy="381000"/>
+          </a:xfrm>
+          <a:prstGeom prst="rect">
+            <a:avLst/>
+          </a:prstGeom>
+          <a:noFill/>
+          <a:ln/>
+        </p:spPr>
+        <p:txBody>
+          <a:bodyPr wrap="square" lIns="0" tIns="0" rIns="0" bIns="0" rtlCol="0" anchor="ctr"/>
+          <a:lstStyle/>
+          <a:p>
+            <a:pPr algn="l" indent="0" marL="0">
+              <a:lnSpc>
+                <a:spcPct val="101900"/>
+              </a:lnSpc>
+              <a:buNone/>
+            </a:pPr>
+            <a:r>
+              <a:rPr lang="ko-KR" altLang="en-US" sz="2000" dirty="0">
                 <a:solidFill>
                   <a:schemeClr val="accent4"/>
                 </a:solidFill>
@@ -8717,42 +8907,46 @@
                 <a:ea typeface="Paperlogy 5 Medium" pitchFamily="34" charset="-127"/>
                 <a:cs typeface="Paperlogy 5 Medium" pitchFamily="34" charset="-120"/>
               </a:rPr>
-              <a:t>훈련에 참여해주신 유관기관 및</a:t>
-            </a:r>
-            <a:endParaRPr lang="ko-KR" sz="1900" dirty="0"/>
-          </a:p>
-          <a:p>
-            <a:pPr algn="l" indent="0" marL="0">
-              <a:lnSpc>
-                <a:spcPct val="127400"/>
-              </a:lnSpc>
-              <a:buNone/>
-            </a:pPr>
-            <a:r>
-              <a:rPr lang="ko-KR" altLang="en-US" sz="1900" dirty="0">
-                <a:solidFill>
-                  <a:schemeClr val="accent4"/>
-                </a:solidFill>
-                <a:latin typeface="Paperlogy 5 Medium" pitchFamily="34" charset="0"/>
-                <a:ea typeface="Paperlogy 5 Medium" pitchFamily="34" charset="-127"/>
-                <a:cs typeface="Paperlogy 5 Medium" pitchFamily="34" charset="-120"/>
-              </a:rPr>
-              <a:t>관계자 여러분께 감사드립니다.</a:t>
-            </a:r>
-            <a:endParaRPr lang="ko-KR" sz="1900" dirty="0"/>
-          </a:p>
-        </p:txBody>
-      </p:sp>
-      <p:sp>
-        <p:nvSpPr>
-          <p:cNvPr id="6" name="Text 3"/>
-          <p:cNvSpPr txBox="1"/>
-          <p:nvPr/>
-        </p:nvSpPr>
-        <p:spPr>
-          <a:xfrm>
-            <a:off x="685800" y="5219700"/>
-            <a:ext cx="4572000" cy="285750"/>
+              <a:t>훈련에 참여해주신 유관기관 및 관계자 여러분께 감사드립니다.</a:t>
+            </a:r>
+            <a:endParaRPr lang="ko-KR" sz="2000" dirty="0"/>
+          </a:p>
+        </p:txBody>
+      </p:sp>
+      <p:sp>
+        <p:nvSpPr>
+          <p:cNvPr id="5" name="Info band"/>
+          <p:cNvSpPr/>
+          <p:nvPr/>
+        </p:nvSpPr>
+        <p:spPr>
+          <a:xfrm>
+            <a:off x="685800" y="4876800"/>
+            <a:ext cx="10820400" cy="1066800"/>
+          </a:xfrm>
+          <a:prstGeom prst="roundRect">
+            <a:avLst>
+              <a:gd name="adj" fmla="val 16071"/>
+            </a:avLst>
+          </a:prstGeom>
+          <a:solidFill>
+            <a:schemeClr val="bg1">
+              <a:alpha val="6000"/>
+            </a:schemeClr>
+          </a:solidFill>
+          <a:ln/>
+        </p:spPr>
+      </p:sp>
+      <p:sp>
+        <p:nvSpPr>
+          <p:cNvPr id="6" name="Text 4"/>
+          <p:cNvSpPr txBox="1"/>
+          <p:nvPr/>
+        </p:nvSpPr>
+        <p:spPr>
+          <a:xfrm>
+            <a:off x="990600" y="5086350"/>
+            <a:ext cx="4343400" cy="228600"/>
           </a:xfrm>
           <a:prstGeom prst="rect">
             <a:avLst/>
@@ -8771,30 +8965,95 @@
               <a:buNone/>
             </a:pPr>
             <a:r>
-              <a:rPr lang="ko-KR" altLang="en-US" sz="1600" dirty="0">
+              <a:rPr lang="ko-KR" altLang="en-US" sz="1300" dirty="0">
                 <a:solidFill>
                   <a:schemeClr val="accent3"/>
+                </a:solidFill>
+                <a:latin typeface="Paperlogy 6 SemiBold" pitchFamily="34" charset="0"/>
+                <a:ea typeface="Paperlogy 6 SemiBold" pitchFamily="34" charset="-127"/>
+                <a:cs typeface="Paperlogy 6 SemiBold" pitchFamily="34" charset="-120"/>
+              </a:rPr>
+              <a:t>훈련</a:t>
+            </a:r>
+            <a:endParaRPr lang="ko-KR" sz="1300" dirty="0"/>
+          </a:p>
+        </p:txBody>
+      </p:sp>
+      <p:sp>
+        <p:nvSpPr>
+          <p:cNvPr id="7" name="Text 5"/>
+          <p:cNvSpPr txBox="1"/>
+          <p:nvPr/>
+        </p:nvSpPr>
+        <p:spPr>
+          <a:xfrm>
+            <a:off x="990600" y="5353050"/>
+            <a:ext cx="4343400" cy="323850"/>
+          </a:xfrm>
+          <a:prstGeom prst="rect">
+            <a:avLst/>
+          </a:prstGeom>
+          <a:noFill/>
+          <a:ln/>
+        </p:spPr>
+        <p:txBody>
+          <a:bodyPr wrap="square" lIns="0" tIns="0" rIns="0" bIns="0" rtlCol="0" anchor="ctr"/>
+          <a:lstStyle/>
+          <a:p>
+            <a:pPr algn="l" indent="0" marL="0">
+              <a:lnSpc>
+                <a:spcPct val="101900"/>
+              </a:lnSpc>
+              <a:buNone/>
+            </a:pPr>
+            <a:r>
+              <a:rPr lang="ko-KR" altLang="en-US" sz="1700" dirty="0">
+                <a:solidFill>
+                  <a:schemeClr val="bg1"/>
                 </a:solidFill>
                 <a:latin typeface="Paperlogy 7 Bold" pitchFamily="34" charset="0"/>
                 <a:ea typeface="Paperlogy 7 Bold" pitchFamily="34" charset="-127"/>
                 <a:cs typeface="Paperlogy 7 Bold" pitchFamily="34" charset="-120"/>
               </a:rPr>
-              <a:t>2026 재난대응 안전한국훈련</a:t>
-            </a:r>
-            <a:endParaRPr lang="ko-KR" sz="1600" dirty="0"/>
-          </a:p>
-        </p:txBody>
-      </p:sp>
-      <p:sp>
-        <p:nvSpPr>
-          <p:cNvPr id="7" name="Text 4"/>
-          <p:cNvSpPr txBox="1"/>
-          <p:nvPr/>
-        </p:nvSpPr>
-        <p:spPr>
-          <a:xfrm>
-            <a:off x="685800" y="5581650"/>
-            <a:ext cx="5715000" cy="266700"/>
+              <a:t>2026 재난대응 안전한국훈련 · 온석터널</a:t>
+            </a:r>
+            <a:endParaRPr lang="ko-KR" sz="1700" dirty="0"/>
+          </a:p>
+        </p:txBody>
+      </p:sp>
+      <p:sp>
+        <p:nvSpPr>
+          <p:cNvPr id="8" name="Shape 6"/>
+          <p:cNvSpPr/>
+          <p:nvPr/>
+        </p:nvSpPr>
+        <p:spPr>
+          <a:xfrm>
+            <a:off x="5562600" y="5143500"/>
+            <a:ext cx="0" cy="533400"/>
+          </a:xfrm>
+          <a:prstGeom prst="line">
+            <a:avLst/>
+          </a:prstGeom>
+          <a:noFill/>
+          <a:ln w="14288">
+            <a:solidFill>
+              <a:schemeClr val="accent1"/>
+            </a:solidFill>
+            <a:prstDash val="solid"/>
+          </a:ln>
+        </p:spPr>
+      </p:sp>
+      <p:sp>
+        <p:nvSpPr>
+          <p:cNvPr id="9" name="Text 7"/>
+          <p:cNvSpPr txBox="1"/>
+          <p:nvPr/>
+        </p:nvSpPr>
+        <p:spPr>
+          <a:xfrm>
+            <a:off x="5791200" y="5086350"/>
+            <a:ext cx="4343400" cy="228600"/>
           </a:xfrm>
           <a:prstGeom prst="rect">
             <a:avLst/>
@@ -8813,17 +9072,59 @@
               <a:buNone/>
             </a:pPr>
             <a:r>
-              <a:rPr lang="ko-KR" altLang="en-US" sz="1600" dirty="0">
+              <a:rPr lang="ko-KR" altLang="en-US" sz="1300" dirty="0">
+                <a:solidFill>
+                  <a:schemeClr val="accent3"/>
+                </a:solidFill>
+                <a:latin typeface="Paperlogy 6 SemiBold" pitchFamily="34" charset="0"/>
+                <a:ea typeface="Paperlogy 6 SemiBold" pitchFamily="34" charset="-127"/>
+                <a:cs typeface="Paperlogy 6 SemiBold" pitchFamily="34" charset="-120"/>
+              </a:rPr>
+              <a:t>주관</a:t>
+            </a:r>
+            <a:endParaRPr lang="ko-KR" sz="1300" dirty="0"/>
+          </a:p>
+        </p:txBody>
+      </p:sp>
+      <p:sp>
+        <p:nvSpPr>
+          <p:cNvPr id="10" name="Text 8"/>
+          <p:cNvSpPr txBox="1"/>
+          <p:nvPr/>
+        </p:nvSpPr>
+        <p:spPr>
+          <a:xfrm>
+            <a:off x="5791200" y="5353050"/>
+            <a:ext cx="4343400" cy="323850"/>
+          </a:xfrm>
+          <a:prstGeom prst="rect">
+            <a:avLst/>
+          </a:prstGeom>
+          <a:noFill/>
+          <a:ln/>
+        </p:spPr>
+        <p:txBody>
+          <a:bodyPr wrap="square" lIns="0" tIns="0" rIns="0" bIns="0" rtlCol="0" anchor="ctr"/>
+          <a:lstStyle/>
+          <a:p>
+            <a:pPr algn="l" indent="0" marL="0">
+              <a:lnSpc>
+                <a:spcPct val="101900"/>
+              </a:lnSpc>
+              <a:buNone/>
+            </a:pPr>
+            <a:r>
+              <a:rPr lang="ko-KR" altLang="en-US" sz="1700" dirty="0">
                 <a:solidFill>
                   <a:schemeClr val="bg1"/>
                 </a:solidFill>
-                <a:latin typeface="Paperlogy 5 Medium" pitchFamily="34" charset="0"/>
-                <a:ea typeface="Paperlogy 5 Medium" pitchFamily="34" charset="-127"/>
-                <a:cs typeface="Paperlogy 5 Medium" pitchFamily="34" charset="-120"/>
-              </a:rPr>
-              <a:t>예산국토관리사무소  시설안전관리과</a:t>
-            </a:r>
-            <a:endParaRPr lang="ko-KR" sz="1600" dirty="0"/>
+                <a:latin typeface="Paperlogy 7 Bold" pitchFamily="34" charset="0"/>
+                <a:ea typeface="Paperlogy 7 Bold" pitchFamily="34" charset="-127"/>
+                <a:cs typeface="Paperlogy 7 Bold" pitchFamily="34" charset="-120"/>
+              </a:rPr>
+              <a:t>예산국토관리사무소 시설안전관리과</a:t>
+            </a:r>
+            <a:endParaRPr lang="ko-KR" sz="1700" dirty="0"/>
           </a:p>
         </p:txBody>
       </p:sp>

</xml_diff>